<commit_message>
feat: switch remaining video queue to seedance 2.5 480p
</commit_message>
<xml_diff>
--- a/deliverables/qiniu-langya-internal-review-v1.pptx
+++ b/deliverables/qiniu-langya-internal-review-v1.pptx
@@ -32192,7 +32192,7 @@
                   <a:srgbClr val="FBF8F1"/>
                 </a:solidFill>
               </a:rPr>
-              <a:t>模型组合：图片负责稳定参考，视频负责动作延续</a:t>
+              <a:t>模型组合：图片负责稳定参考，Seedance 2.5 负责全片动作生产</a:t>
             </a:r>
           </a:p>
         </p:txBody>
@@ -32313,7 +32313,7 @@
                   <a:srgbClr val="B9B0A7"/>
                 </a:solidFill>
               </a:rPr>
-              <a:t>这是用户手动查看基准素材后的制作优先组合，不表述为统计排名。</a:t>
+              <a:t>这是基准测试后的生产切换：代表性样片验证 H3 链路后，全片改用 Seedance 2.5 480P 批量生产。</a:t>
             </a:r>
           </a:p>
         </p:txBody>
@@ -33578,7 +33578,7 @@
                   <a:srgbClr val="F4EFE6"/>
                 </a:solidFill>
               </a:rPr>
-              <a:t>MiniMax H3</a:t>
+              <a:t>Seedance 2.5</a:t>
             </a:r>
           </a:p>
         </p:txBody>
@@ -33736,7 +33736,7 @@
                   <a:srgbClr val="F4EFE6"/>
                 </a:solidFill>
               </a:rPr>
-              <a:t>视频 / 正式片段</a:t>
+              <a:t>视频 / 全片正式生产</a:t>
             </a:r>
           </a:p>
         </p:txBody>
@@ -33857,7 +33857,7 @@
                   <a:srgbClr val="B33A2C"/>
                 </a:solidFill>
               </a:rPr>
-              <a:t>768P · 9:16 · 143 积分 / 秒</a:t>
+              <a:t>480P · 9:16 · 92 积分 / 秒</a:t>
             </a:r>
           </a:p>
         </p:txBody>
@@ -34049,7 +34049,7 @@
                   <a:srgbClr val="A8B6C7"/>
                 </a:solidFill>
               </a:rPr>
-              <a:t>reference 模式承接已完成关键帧</a:t>
+              <a:t>文生视频直接生产；修复样片保留 reference 链路作为对照</a:t>
             </a:r>
           </a:p>
         </p:txBody>

</xml_diff>

<commit_message>
feat: complete full film delivery
</commit_message>
<xml_diff>
--- a/deliverables/qiniu-langya-internal-review-v1.pptx
+++ b/deliverables/qiniu-langya-internal-review-v1.pptx
@@ -5350,7 +5350,7 @@
                   <a:srgbClr val="C79B5B"/>
                 </a:solidFill>
               </a:rPr>
-              <a:t>全片批量生成中</a:t>
+              <a:t>全片已生成，待内部终审</a:t>
             </a:r>
           </a:p>
         </p:txBody>
@@ -11520,7 +11520,7 @@
                   <a:srgbClr val="17161B"/>
                 </a:solidFill>
               </a:rPr>
-              <a:t>67 段已进入队列，仍需逐段复核</a:t>
+              <a:t>67 段已生成，完成最终逐段复核</a:t>
             </a:r>
           </a:p>
         </p:txBody>
@@ -11994,7 +11994,7 @@
                   <a:srgbClr val="17161B"/>
                 </a:solidFill>
               </a:rPr>
-              <a:t>声音、旁白、书法字幕、最终混剪未完成</a:t>
+              <a:t>书法字幕与最终混剪已完成；声音仍可继续增强</a:t>
             </a:r>
           </a:p>
         </p:txBody>
@@ -12152,7 +12152,7 @@
                   <a:srgbClr val="17161B"/>
                 </a:solidFill>
               </a:rPr>
-              <a:t>全片成片状态：未完成</a:t>
+              <a:t>全片成片状态：已生成，待终审</a:t>
             </a:r>
           </a:p>
         </p:txBody>
@@ -12857,7 +12857,7 @@
                   <a:srgbClr val="FBF8F1"/>
                 </a:solidFill>
               </a:rPr>
-              <a:t>从三条样片，进入三集全片的批量生成闭环</a:t>
+              <a:t>三集全片已生成，进入内部终审闭环</a:t>
             </a:r>
           </a:p>
         </p:txBody>
@@ -12978,7 +12978,7 @@
                   <a:srgbClr val="B9B0A7"/>
                 </a:solidFill>
               </a:rPr>
-              <a:t>下一步的关键不是再做概念，而是把已验证的节点结构复制到每个 exact scope。</a:t>
+              <a:t>下一步是逐段检查实际帧、确认声音与字幕，并完成内部终审交付。</a:t>
             </a:r>
           </a:p>
         </p:txBody>
@@ -13296,7 +13296,7 @@
                   <a:srgbClr val="F4EFE6"/>
                 </a:solidFill>
               </a:rPr>
-              <a:t>批量生产中锁定</a:t>
+              <a:t>最终终审锁定</a:t>
             </a:r>
           </a:p>
         </p:txBody>
@@ -15441,7 +15441,7 @@
                   <a:srgbClr val="FBF8F1"/>
                 </a:solidFill>
               </a:rPr>
-              <a:t>当前状态：样片链路已打通，全片已进入批量生产</a:t>
+              <a:t>当前状态：67 段全片已生成，进入最终内部终审</a:t>
             </a:r>
           </a:p>
         </p:txBody>

</xml_diff>